<commit_message>
Refresh evidence snapshot with Stage 1 results (NSMPA 0.7.4)
- Workbook and deck regenerated: 1,346 evidence rows, 145 expert voices,
  336 opposing excerpts; all 50 standards/support organizations now included.
- Labels reflect the 0.7.4 classifier (stored excerpts re-judged, no refetch).
- Same privacy handling: automated redaction (781 replacements, audited) and the
  3 rows concerning the author's own case withheld, as stated in the Read Me.
- README and evidence/README updated: 67 organizations researched, 31 with a
  determined position; still no excerpt human-verified.

Co-Authored-By: Claude Opus 5.5 <noreply@anthropic.com>
Claude-Session: https://claude.ai/code/session_011zGmumriGwfpJuWqNhFRuQ
</commit_message>
<xml_diff>
--- a/evidence/2026-10-08/NSMPA_presentation.pptx
+++ b/evidence/2026-10-08/NSMPA_presentation.pptx
@@ -207,7 +207,7 @@
                   <c:v>4</c:v>
                 </c:pt>
                 <c:pt idx="2">
-                  <c:v>0</c:v>
+                  <c:v>4</c:v>
                 </c:pt>
               </c:numCache>
             </c:numRef>
@@ -365,7 +365,7 @@
                   <c:v>3</c:v>
                 </c:pt>
                 <c:pt idx="2">
-                  <c:v>0</c:v>
+                  <c:v>3</c:v>
                 </c:pt>
               </c:numCache>
             </c:numRef>
@@ -734,19 +734,19 @@
                 <c:formatCode>General</c:formatCode>
                 <c:ptCount val="5"/>
                 <c:pt idx="0">
-                  <c:v>0</c:v>
+                  <c:v>3</c:v>
                 </c:pt>
                 <c:pt idx="1">
-                  <c:v>0</c:v>
+                  <c:v>4</c:v>
                 </c:pt>
                 <c:pt idx="2">
-                  <c:v>0</c:v>
+                  <c:v>1</c:v>
                 </c:pt>
                 <c:pt idx="3">
                   <c:v>1</c:v>
                 </c:pt>
                 <c:pt idx="4">
-                  <c:v>0</c:v>
+                  <c:v>37</c:v>
                 </c:pt>
               </c:numCache>
             </c:numRef>
@@ -828,7 +828,6 @@
         </c:txPr>
         <c:crossAx val="-2068027336"/>
         <c:crosses val="autoZero"/>
-        <c:majorUnit val="1.0"/>
       </c:valAx>
     </c:plotArea>
     <c:legend>
@@ -3885,7 +3884,7 @@
                 </a:solidFill>
                 <a:latin typeface="Arial"/>
               </a:rPr>
-              <a:t>EVIDENCE BRIEFING · 2026-10-08 17:14 UTC</a:t>
+              <a:t>EVIDENCE BRIEFING · 2026-10-08 18:30 UTC</a:t>
             </a:r>
           </a:p>
         </p:txBody>
@@ -4018,7 +4017,7 @@
                 </a:solidFill>
                 <a:latin typeface="Arial"/>
               </a:rPr>
-              <a:t>Prepared with NSMPA 0.7.2 · scope: latest stance per entity (excluded runs omitted) · names of private individuals withheld (automated redaction)</a:t>
+              <a:t>Prepared with NSMPA 0.7.4 · scope: latest stance per entity (excluded runs omitted) · names of private individuals withheld (automated redaction)</a:t>
             </a:r>
           </a:p>
         </p:txBody>
@@ -5963,7 +5962,7 @@
                 </a:solidFill>
                 <a:latin typeface="Arial"/>
               </a:rPr>
-              <a:t>“It runs counter to our core mission of informing the public and creating the first draft of history.”</a:t>
+              <a:t>“News leaders from The Boston Globe, Chicago Tribune, Chattanooga Times Free Press and Cleveland.com will share their newsrooms’ editorial policies and the philosophies driving them — including managing requests to remove, de-index or alter “the first draft of ”</a:t>
             </a:r>
           </a:p>
           <a:p>
@@ -5979,7 +5978,7 @@
                 </a:solidFill>
                 <a:latin typeface="Arial"/>
               </a:rPr>
-              <a:t>— Dan MacLeod</a:t>
+              <a:t>— RJI Online RJI Fellows Class of 2020–2021</a:t>
             </a:r>
           </a:p>
           <a:p>
@@ -5995,7 +5994,7 @@
                 </a:solidFill>
                 <a:latin typeface="Arial"/>
               </a:rPr>
-              <a:t>https://www.bangordailynews.com/2021/01/25/news/were-changing-our-policy-on-old-crime-stor · UNVERIFIED</a:t>
+              <a:t>https://rjionline.org/events/crime-mugshots-and-takedown-requests-editors-share-newsroom-a · UNVERIFIED</a:t>
             </a:r>
           </a:p>
         </p:txBody>
@@ -6079,7 +6078,7 @@
                 </a:solidFill>
                 <a:latin typeface="Arial"/>
               </a:rPr>
-              <a:t>“Yamin said editors at The Michigan Daily were typically “sticklers” about leaving published material untouched and refusing anonymity to students on either side of the debate over the war in Gaza, in order to have a permanent record of what sources or writers ”</a:t>
+              <a:t>“It runs counter to our core mission of informing the public and creating the first draft of history.”</a:t>
             </a:r>
           </a:p>
           <a:p>
@@ -6095,7 +6094,7 @@
                 </a:solidFill>
                 <a:latin typeface="Arial"/>
               </a:rPr>
-              <a:t>— megan_cattel@harvard.edu</a:t>
+              <a:t>— Dan MacLeod</a:t>
             </a:r>
           </a:p>
           <a:p>
@@ -6111,7 +6110,7 @@
                 </a:solidFill>
                 <a:latin typeface="Arial"/>
               </a:rPr>
-              <a:t>https://niemanreports.org/campus-newspapers-student-journalists-trump-editorial-policies-f · UNVERIFIED</a:t>
+              <a:t>https://www.bangordailynews.com/2021/01/25/news/were-changing-our-policy-on-old-crime-stor · UNVERIFIED</a:t>
             </a:r>
           </a:p>
         </p:txBody>
@@ -6195,7 +6194,7 @@
                 </a:solidFill>
                 <a:latin typeface="Arial"/>
               </a:rPr>
-              <a:t>“Rather than writing a blanket policy (“we’ll never change old crime stories” or “we’ll anonymize a story anytime a subject asks”), create an open-ended framework and come up with a list of questions to discuss for each case.”</a:t>
+              <a:t>“Yamin said editors at The Michigan Daily were typically “sticklers” about leaving published material untouched and refusing anonymity to students on either side of the debate over the war in Gaza, in order to have a permanent record of what sources or writers ”</a:t>
             </a:r>
           </a:p>
           <a:p>
@@ -6211,7 +6210,7 @@
                 </a:solidFill>
                 <a:latin typeface="Arial"/>
               </a:rPr>
-              <a:t>— Taylor Blatchford</a:t>
+              <a:t>— megan_cattel@harvard.edu</a:t>
             </a:r>
           </a:p>
           <a:p>
@@ -6227,7 +6226,7 @@
                 </a:solidFill>
                 <a:latin typeface="Arial"/>
               </a:rPr>
-              <a:t>https://www.poynter.org/newsletters/2021/how-student-newsrooms-can-set-a-framework-for-req · UNVERIFIED</a:t>
+              <a:t>https://niemanreports.org/campus-newspapers-student-journalists-trump-editorial-policies-f · UNVERIFIED</a:t>
             </a:r>
           </a:p>
         </p:txBody>
@@ -6311,7 +6310,7 @@
                 </a:solidFill>
                 <a:latin typeface="Arial"/>
               </a:rPr>
-              <a:t>“Source remorse is not a right reason to unpublish: We should not remove published information because sources change their minds about what they told a journalist, or decide, following publication, that they do not want news about them accessed through a searc”</a:t>
+              <a:t>“Rather than writing a blanket policy (“we’ll never change old crime stories” or “we’ll anonymize a story anytime a subject asks”), create an open-ended framework and come up with a list of questions to discuss for each case.”</a:t>
             </a:r>
           </a:p>
           <a:p>
@@ -6327,7 +6326,7 @@
                 </a:solidFill>
                 <a:latin typeface="Arial"/>
               </a:rPr>
-              <a:t>— Monique Durette</a:t>
+              <a:t>— Taylor Blatchford</a:t>
             </a:r>
           </a:p>
           <a:p>
@@ -6343,7 +6342,7 @@
                 </a:solidFill>
                 <a:latin typeface="Arial"/>
               </a:rPr>
-              <a:t>https://caj.ca/fr/the-ethics-of-unpublishing/ · UNVERIFIED</a:t>
+              <a:t>https://www.poynter.org/newsletters/2021/how-student-newsrooms-can-set-a-framework-for-req · UNVERIFIED</a:t>
             </a:r>
           </a:p>
         </p:txBody>
@@ -6596,7 +6595,7 @@
                 </a:solidFill>
                 <a:latin typeface="Arial"/>
               </a:rPr>
-              <a:t>In this dataset, 5 organization(s) allow or practice de-indexing or anonymization while keeping the article published; 1 organization(s) explicitly reject unpublishing.</a:t>
+              <a:t>In this dataset, 9 organization(s) allow or practice de-indexing or anonymization while keeping the article published; 2 organization(s) explicitly reject unpublishing.</a:t>
             </a:r>
           </a:p>
           <a:p>
@@ -6651,7 +6650,7 @@
                 </a:solidFill>
                 <a:latin typeface="Arial"/>
               </a:rPr>
-              <a:t>All 313 opposing excerpts: workbook sheet 'Opposing Evidence'.</a:t>
+              <a:t>All 336 opposing excerpts: workbook sheet 'Opposing Evidence'.</a:t>
             </a:r>
           </a:p>
         </p:txBody>
@@ -7088,7 +7087,7 @@
                 </a:solidFill>
                 <a:latin typeface="Arial"/>
               </a:rPr>
-              <a:t>• Standards &amp; support orgs: preliminary — minimum researched entities; research coverage of universe; human review of findings</a:t>
+              <a:t>• Standards &amp; support orgs: preliminary — human review of findings; source verification of evidence</a:t>
             </a:r>
           </a:p>
         </p:txBody>
@@ -7837,7 +7836,7 @@
                 </a:solidFill>
                 <a:latin typeface="Arial"/>
               </a:rPr>
-              <a:t>Standards &amp; support orgs: 1 researched (preliminary — counts only); 0 allow relief that keeps the archive; 0 reject unpublishing.</a:t>
+              <a:t>Standards &amp; support orgs: 46 researched (preliminary — counts only); 4 allow relief that keeps the archive; 1 reject unpublishing.</a:t>
             </a:r>
           </a:p>
         </p:txBody>

</xml_diff>